<commit_message>
Added speaking person labels
</commit_message>
<xml_diff>
--- a/TAS.pptx
+++ b/TAS.pptx
@@ -812,7 +812,7 @@
   <p:cSld>
     <p:spTree>
       <p:nvGrpSpPr>
-        <p:cNvPr id="128" name="Shape 128"/>
+        <p:cNvPr id="137" name="Shape 137"/>
         <p:cNvGrpSpPr/>
         <p:nvPr/>
       </p:nvGrpSpPr>
@@ -826,7 +826,7 @@
       </p:grpSpPr>
       <p:sp>
         <p:nvSpPr>
-          <p:cNvPr id="129" name="Google Shape;129;h99764deb354f989_14_12:notes"/>
+          <p:cNvPr id="138" name="Google Shape;138;h99764deb354f989_14_12:notes"/>
           <p:cNvSpPr/>
           <p:nvPr>
             <p:ph idx="2" type="sldImg"/>
@@ -861,7 +861,7 @@
       </p:sp>
       <p:sp>
         <p:nvSpPr>
-          <p:cNvPr id="130" name="Google Shape;130;h99764deb354f989_14_12:notes"/>
+          <p:cNvPr id="139" name="Google Shape;139;h99764deb354f989_14_12:notes"/>
           <p:cNvSpPr txBox="1"/>
           <p:nvPr>
             <p:ph idx="1" type="body"/>
@@ -911,7 +911,7 @@
   <p:cSld>
     <p:spTree>
       <p:nvGrpSpPr>
-        <p:cNvPr id="135" name="Shape 135"/>
+        <p:cNvPr id="145" name="Shape 145"/>
         <p:cNvGrpSpPr/>
         <p:nvPr/>
       </p:nvGrpSpPr>
@@ -925,7 +925,7 @@
       </p:grpSpPr>
       <p:sp>
         <p:nvSpPr>
-          <p:cNvPr id="136" name="Google Shape;136;h99764deb354f989_14_21:notes"/>
+          <p:cNvPr id="146" name="Google Shape;146;h99764deb354f989_14_21:notes"/>
           <p:cNvSpPr/>
           <p:nvPr>
             <p:ph idx="2" type="sldImg"/>
@@ -960,7 +960,7 @@
       </p:sp>
       <p:sp>
         <p:nvSpPr>
-          <p:cNvPr id="137" name="Google Shape;137;h99764deb354f989_14_21:notes"/>
+          <p:cNvPr id="147" name="Google Shape;147;h99764deb354f989_14_21:notes"/>
           <p:cNvSpPr txBox="1"/>
           <p:nvPr>
             <p:ph idx="1" type="body"/>
@@ -1010,7 +1010,7 @@
   <p:cSld>
     <p:spTree>
       <p:nvGrpSpPr>
-        <p:cNvPr id="143" name="Shape 143"/>
+        <p:cNvPr id="153" name="Shape 153"/>
         <p:cNvGrpSpPr/>
         <p:nvPr/>
       </p:nvGrpSpPr>
@@ -1024,7 +1024,7 @@
       </p:grpSpPr>
       <p:sp>
         <p:nvSpPr>
-          <p:cNvPr id="144" name="Google Shape;144;h99764deb354f989_14_37:notes"/>
+          <p:cNvPr id="154" name="Google Shape;154;h99764deb354f989_14_37:notes"/>
           <p:cNvSpPr/>
           <p:nvPr>
             <p:ph idx="2" type="sldImg"/>
@@ -1059,7 +1059,7 @@
       </p:sp>
       <p:sp>
         <p:nvSpPr>
-          <p:cNvPr id="145" name="Google Shape;145;h99764deb354f989_14_37:notes"/>
+          <p:cNvPr id="155" name="Google Shape;155;h99764deb354f989_14_37:notes"/>
           <p:cNvSpPr txBox="1"/>
           <p:nvPr>
             <p:ph idx="1" type="body"/>
@@ -1109,7 +1109,7 @@
   <p:cSld>
     <p:spTree>
       <p:nvGrpSpPr>
-        <p:cNvPr id="61" name="Shape 61"/>
+        <p:cNvPr id="62" name="Shape 62"/>
         <p:cNvGrpSpPr/>
         <p:nvPr/>
       </p:nvGrpSpPr>
@@ -1123,7 +1123,7 @@
       </p:grpSpPr>
       <p:sp>
         <p:nvSpPr>
-          <p:cNvPr id="62" name="Google Shape;62;h30b8a0db82fc3989_0_0:notes"/>
+          <p:cNvPr id="63" name="Google Shape;63;h30b8a0db82fc3989_0_0:notes"/>
           <p:cNvSpPr/>
           <p:nvPr>
             <p:ph idx="2" type="sldImg"/>
@@ -1158,7 +1158,7 @@
       </p:sp>
       <p:sp>
         <p:nvSpPr>
-          <p:cNvPr id="63" name="Google Shape;63;h30b8a0db82fc3989_0_0:notes"/>
+          <p:cNvPr id="64" name="Google Shape;64;h30b8a0db82fc3989_0_0:notes"/>
           <p:cNvSpPr txBox="1"/>
           <p:nvPr>
             <p:ph idx="1" type="body"/>
@@ -1208,7 +1208,7 @@
   <p:cSld>
     <p:spTree>
       <p:nvGrpSpPr>
-        <p:cNvPr id="69" name="Shape 69"/>
+        <p:cNvPr id="71" name="Shape 71"/>
         <p:cNvGrpSpPr/>
         <p:nvPr/>
       </p:nvGrpSpPr>
@@ -1222,7 +1222,7 @@
       </p:grpSpPr>
       <p:sp>
         <p:nvSpPr>
-          <p:cNvPr id="70" name="Google Shape;70;h30b8a0db82fc3989_0_128:notes"/>
+          <p:cNvPr id="72" name="Google Shape;72;h30b8a0db82fc3989_0_128:notes"/>
           <p:cNvSpPr/>
           <p:nvPr>
             <p:ph idx="2" type="sldImg"/>
@@ -1257,7 +1257,7 @@
       </p:sp>
       <p:sp>
         <p:nvSpPr>
-          <p:cNvPr id="71" name="Google Shape;71;h30b8a0db82fc3989_0_128:notes"/>
+          <p:cNvPr id="73" name="Google Shape;73;h30b8a0db82fc3989_0_128:notes"/>
           <p:cNvSpPr txBox="1"/>
           <p:nvPr>
             <p:ph idx="1" type="body"/>
@@ -1307,7 +1307,7 @@
   <p:cSld>
     <p:spTree>
       <p:nvGrpSpPr>
-        <p:cNvPr id="77" name="Shape 77"/>
+        <p:cNvPr id="80" name="Shape 80"/>
         <p:cNvGrpSpPr/>
         <p:nvPr/>
       </p:nvGrpSpPr>
@@ -1321,7 +1321,7 @@
       </p:grpSpPr>
       <p:sp>
         <p:nvSpPr>
-          <p:cNvPr id="78" name="Google Shape;78;h30b8a0db82fc3989_0_133:notes"/>
+          <p:cNvPr id="81" name="Google Shape;81;h30b8a0db82fc3989_0_133:notes"/>
           <p:cNvSpPr/>
           <p:nvPr>
             <p:ph idx="2" type="sldImg"/>
@@ -1356,7 +1356,7 @@
       </p:sp>
       <p:sp>
         <p:nvSpPr>
-          <p:cNvPr id="79" name="Google Shape;79;h30b8a0db82fc3989_0_133:notes"/>
+          <p:cNvPr id="82" name="Google Shape;82;h30b8a0db82fc3989_0_133:notes"/>
           <p:cNvSpPr txBox="1"/>
           <p:nvPr>
             <p:ph idx="1" type="body"/>
@@ -1406,7 +1406,7 @@
   <p:cSld>
     <p:spTree>
       <p:nvGrpSpPr>
-        <p:cNvPr id="86" name="Shape 86"/>
+        <p:cNvPr id="90" name="Shape 90"/>
         <p:cNvGrpSpPr/>
         <p:nvPr/>
       </p:nvGrpSpPr>
@@ -1420,7 +1420,7 @@
       </p:grpSpPr>
       <p:sp>
         <p:nvSpPr>
-          <p:cNvPr id="87" name="Google Shape;87;h30b8a0db82fc3989_0_5:notes"/>
+          <p:cNvPr id="91" name="Google Shape;91;h30b8a0db82fc3989_0_5:notes"/>
           <p:cNvSpPr/>
           <p:nvPr>
             <p:ph idx="2" type="sldImg"/>
@@ -1455,7 +1455,7 @@
       </p:sp>
       <p:sp>
         <p:nvSpPr>
-          <p:cNvPr id="88" name="Google Shape;88;h30b8a0db82fc3989_0_5:notes"/>
+          <p:cNvPr id="92" name="Google Shape;92;h30b8a0db82fc3989_0_5:notes"/>
           <p:cNvSpPr txBox="1"/>
           <p:nvPr>
             <p:ph idx="1" type="body"/>
@@ -1505,7 +1505,7 @@
   <p:cSld>
     <p:spTree>
       <p:nvGrpSpPr>
-        <p:cNvPr id="98" name="Shape 98"/>
+        <p:cNvPr id="103" name="Shape 103"/>
         <p:cNvGrpSpPr/>
         <p:nvPr/>
       </p:nvGrpSpPr>
@@ -1519,7 +1519,7 @@
       </p:grpSpPr>
       <p:sp>
         <p:nvSpPr>
-          <p:cNvPr id="99" name="Google Shape;99;h30b8a0db82fc3989_0_10:notes"/>
+          <p:cNvPr id="104" name="Google Shape;104;h30b8a0db82fc3989_0_10:notes"/>
           <p:cNvSpPr/>
           <p:nvPr>
             <p:ph idx="2" type="sldImg"/>
@@ -1554,7 +1554,7 @@
       </p:sp>
       <p:sp>
         <p:nvSpPr>
-          <p:cNvPr id="100" name="Google Shape;100;h30b8a0db82fc3989_0_10:notes"/>
+          <p:cNvPr id="105" name="Google Shape;105;h30b8a0db82fc3989_0_10:notes"/>
           <p:cNvSpPr txBox="1"/>
           <p:nvPr>
             <p:ph idx="1" type="body"/>
@@ -1604,7 +1604,7 @@
   <p:cSld>
     <p:spTree>
       <p:nvGrpSpPr>
-        <p:cNvPr id="107" name="Shape 107"/>
+        <p:cNvPr id="113" name="Shape 113"/>
         <p:cNvGrpSpPr/>
         <p:nvPr/>
       </p:nvGrpSpPr>
@@ -1618,7 +1618,7 @@
       </p:grpSpPr>
       <p:sp>
         <p:nvSpPr>
-          <p:cNvPr id="108" name="Google Shape;108;h30b8a0db82fc3989_0_15:notes"/>
+          <p:cNvPr id="114" name="Google Shape;114;h30b8a0db82fc3989_0_15:notes"/>
           <p:cNvSpPr/>
           <p:nvPr>
             <p:ph idx="2" type="sldImg"/>
@@ -1653,7 +1653,7 @@
       </p:sp>
       <p:sp>
         <p:nvSpPr>
-          <p:cNvPr id="109" name="Google Shape;109;h30b8a0db82fc3989_0_15:notes"/>
+          <p:cNvPr id="115" name="Google Shape;115;h30b8a0db82fc3989_0_15:notes"/>
           <p:cNvSpPr txBox="1"/>
           <p:nvPr>
             <p:ph idx="1" type="body"/>
@@ -1703,7 +1703,7 @@
   <p:cSld>
     <p:spTree>
       <p:nvGrpSpPr>
-        <p:cNvPr id="114" name="Shape 114"/>
+        <p:cNvPr id="121" name="Shape 121"/>
         <p:cNvGrpSpPr/>
         <p:nvPr/>
       </p:nvGrpSpPr>
@@ -1717,7 +1717,7 @@
       </p:grpSpPr>
       <p:sp>
         <p:nvSpPr>
-          <p:cNvPr id="115" name="Google Shape;115;h30b8a0db82fc3989_0_20:notes"/>
+          <p:cNvPr id="122" name="Google Shape;122;h30b8a0db82fc3989_0_20:notes"/>
           <p:cNvSpPr/>
           <p:nvPr>
             <p:ph idx="2" type="sldImg"/>
@@ -1752,7 +1752,7 @@
       </p:sp>
       <p:sp>
         <p:nvSpPr>
-          <p:cNvPr id="116" name="Google Shape;116;h30b8a0db82fc3989_0_20:notes"/>
+          <p:cNvPr id="123" name="Google Shape;123;h30b8a0db82fc3989_0_20:notes"/>
           <p:cNvSpPr txBox="1"/>
           <p:nvPr>
             <p:ph idx="1" type="body"/>
@@ -1802,7 +1802,7 @@
   <p:cSld>
     <p:spTree>
       <p:nvGrpSpPr>
-        <p:cNvPr id="121" name="Shape 121"/>
+        <p:cNvPr id="129" name="Shape 129"/>
         <p:cNvGrpSpPr/>
         <p:nvPr/>
       </p:nvGrpSpPr>
@@ -1816,7 +1816,7 @@
       </p:grpSpPr>
       <p:sp>
         <p:nvSpPr>
-          <p:cNvPr id="122" name="Google Shape;122;h30b8a0db82fc3989_0_163:notes"/>
+          <p:cNvPr id="130" name="Google Shape;130;h30b8a0db82fc3989_0_163:notes"/>
           <p:cNvSpPr/>
           <p:nvPr>
             <p:ph idx="2" type="sldImg"/>
@@ -1851,7 +1851,7 @@
       </p:sp>
       <p:sp>
         <p:nvSpPr>
-          <p:cNvPr id="123" name="Google Shape;123;h30b8a0db82fc3989_0_163:notes"/>
+          <p:cNvPr id="131" name="Google Shape;131;h30b8a0db82fc3989_0_163:notes"/>
           <p:cNvSpPr txBox="1"/>
           <p:nvPr>
             <p:ph idx="1" type="body"/>
@@ -6428,6 +6428,9 @@
     <p:sldLayoutId id="2147483657" r:id="rId10"/>
     <p:sldLayoutId id="2147483658" r:id="rId11"/>
   </p:sldLayoutIdLst>
+  <p:transition spd="med">
+    <p:fade thruBlk="1"/>
+  </p:transition>
   <p:hf dt="0" ftr="0" hdr="0" sldNum="0"/>
   <p:txStyles>
     <p:titleStyle>
@@ -7306,6 +7309,64 @@
           </a:p>
         </p:txBody>
       </p:sp>
+      <p:sp>
+        <p:nvSpPr>
+          <p:cNvPr id="61" name="Google Shape;61;p13"/>
+          <p:cNvSpPr txBox="1"/>
+          <p:nvPr/>
+        </p:nvSpPr>
+        <p:spPr>
+          <a:xfrm>
+            <a:off x="8187150" y="125825"/>
+            <a:ext cx="1462800" cy="220200"/>
+          </a:xfrm>
+          <a:prstGeom prst="rect">
+            <a:avLst/>
+          </a:prstGeom>
+          <a:noFill/>
+          <a:ln>
+            <a:noFill/>
+          </a:ln>
+        </p:spPr>
+        <p:txBody>
+          <a:bodyPr anchorCtr="0" anchor="t" bIns="91425" lIns="91425" spcFirstLastPara="1" rIns="91425" wrap="square" tIns="91425">
+            <a:noAutofit/>
+          </a:bodyPr>
+          <a:lstStyle/>
+          <a:p>
+            <a:pPr indent="0" lvl="0" marL="0" rtl="0" algn="l">
+              <a:spcBef>
+                <a:spcPts val="0"/>
+              </a:spcBef>
+              <a:spcAft>
+                <a:spcPts val="0"/>
+              </a:spcAft>
+              <a:buNone/>
+            </a:pPr>
+            <a:r>
+              <a:rPr lang="ru" sz="1800">
+                <a:solidFill>
+                  <a:schemeClr val="accent3"/>
+                </a:solidFill>
+                <a:latin typeface="Average"/>
+                <a:ea typeface="Average"/>
+                <a:cs typeface="Average"/>
+                <a:sym typeface="Average"/>
+              </a:rPr>
+              <a:t>A.</a:t>
+            </a:r>
+            <a:endParaRPr sz="1800">
+              <a:solidFill>
+                <a:schemeClr val="accent3"/>
+              </a:solidFill>
+              <a:latin typeface="Average"/>
+              <a:ea typeface="Average"/>
+              <a:cs typeface="Average"/>
+              <a:sym typeface="Average"/>
+            </a:endParaRPr>
+          </a:p>
+        </p:txBody>
+      </p:sp>
     </p:spTree>
   </p:cSld>
   <p:clrMapOvr>
@@ -7319,7 +7380,7 @@
   <p:cSld>
     <p:spTree>
       <p:nvGrpSpPr>
-        <p:cNvPr id="131" name="Shape 131"/>
+        <p:cNvPr id="140" name="Shape 140"/>
         <p:cNvGrpSpPr/>
         <p:nvPr/>
       </p:nvGrpSpPr>
@@ -7333,7 +7394,7 @@
       </p:grpSpPr>
       <p:sp>
         <p:nvSpPr>
-          <p:cNvPr id="132" name="Google Shape;132;p22"/>
+          <p:cNvPr id="141" name="Google Shape;141;p22"/>
           <p:cNvSpPr txBox="1"/>
           <p:nvPr>
             <p:ph type="title"/>
@@ -7381,7 +7442,7 @@
       </p:sp>
       <p:sp>
         <p:nvSpPr>
-          <p:cNvPr id="133" name="Google Shape;133;p22"/>
+          <p:cNvPr id="142" name="Google Shape;142;p22"/>
           <p:cNvSpPr txBox="1"/>
           <p:nvPr>
             <p:ph idx="1" type="body"/>
@@ -7438,7 +7499,7 @@
       </p:sp>
       <p:pic>
         <p:nvPicPr>
-          <p:cNvPr id="134" name="Google Shape;134;p22"/>
+          <p:cNvPr id="143" name="Google Shape;143;p22"/>
           <p:cNvPicPr preferRelativeResize="0"/>
           <p:nvPr/>
         </p:nvPicPr>
@@ -7464,6 +7525,76 @@
           </a:ln>
         </p:spPr>
       </p:pic>
+      <p:sp>
+        <p:nvSpPr>
+          <p:cNvPr id="144" name="Google Shape;144;p22"/>
+          <p:cNvSpPr txBox="1"/>
+          <p:nvPr/>
+        </p:nvSpPr>
+        <p:spPr>
+          <a:xfrm>
+            <a:off x="8438800" y="133700"/>
+            <a:ext cx="865200" cy="369600"/>
+          </a:xfrm>
+          <a:prstGeom prst="rect">
+            <a:avLst/>
+          </a:prstGeom>
+          <a:noFill/>
+          <a:ln>
+            <a:noFill/>
+          </a:ln>
+        </p:spPr>
+        <p:txBody>
+          <a:bodyPr anchorCtr="0" anchor="t" bIns="91425" lIns="91425" spcFirstLastPara="1" rIns="91425" wrap="square" tIns="91425">
+            <a:noAutofit/>
+          </a:bodyPr>
+          <a:lstStyle/>
+          <a:p>
+            <a:pPr indent="0" lvl="0" marL="0" rtl="0" algn="l">
+              <a:spcBef>
+                <a:spcPts val="0"/>
+              </a:spcBef>
+              <a:spcAft>
+                <a:spcPts val="0"/>
+              </a:spcAft>
+              <a:buNone/>
+            </a:pPr>
+            <a:r>
+              <a:rPr lang="ru" sz="1800">
+                <a:solidFill>
+                  <a:schemeClr val="accent3"/>
+                </a:solidFill>
+                <a:latin typeface="Average"/>
+                <a:ea typeface="Average"/>
+                <a:cs typeface="Average"/>
+                <a:sym typeface="Average"/>
+              </a:rPr>
+              <a:t>T</a:t>
+            </a:r>
+            <a:r>
+              <a:rPr lang="ru" sz="1800">
+                <a:solidFill>
+                  <a:schemeClr val="accent3"/>
+                </a:solidFill>
+                <a:latin typeface="Average"/>
+                <a:ea typeface="Average"/>
+                <a:cs typeface="Average"/>
+                <a:sym typeface="Average"/>
+              </a:rPr>
+              <a:t>.</a:t>
+            </a:r>
+            <a:endParaRPr sz="1800">
+              <a:solidFill>
+                <a:schemeClr val="accent3"/>
+              </a:solidFill>
+              <a:latin typeface="Average"/>
+              <a:ea typeface="Average"/>
+              <a:cs typeface="Average"/>
+              <a:sym typeface="Average"/>
+            </a:endParaRPr>
+          </a:p>
+        </p:txBody>
+      </p:sp>
     </p:spTree>
   </p:cSld>
   <p:clrMapOvr>
@@ -7477,7 +7608,7 @@
   <p:cSld>
     <p:spTree>
       <p:nvGrpSpPr>
-        <p:cNvPr id="138" name="Shape 138"/>
+        <p:cNvPr id="148" name="Shape 148"/>
         <p:cNvGrpSpPr/>
         <p:nvPr/>
       </p:nvGrpSpPr>
@@ -7491,7 +7622,7 @@
       </p:grpSpPr>
       <p:sp>
         <p:nvSpPr>
-          <p:cNvPr id="139" name="Google Shape;139;p23"/>
+          <p:cNvPr id="149" name="Google Shape;149;p23"/>
           <p:cNvSpPr txBox="1"/>
           <p:nvPr>
             <p:ph type="title"/>
@@ -7539,7 +7670,7 @@
       </p:sp>
       <p:sp>
         <p:nvSpPr>
-          <p:cNvPr id="140" name="Google Shape;140;p23"/>
+          <p:cNvPr id="150" name="Google Shape;150;p23"/>
           <p:cNvSpPr txBox="1"/>
           <p:nvPr>
             <p:ph idx="1" type="body"/>
@@ -7752,7 +7883,7 @@
       </p:sp>
       <p:sp>
         <p:nvSpPr>
-          <p:cNvPr id="141" name="Google Shape;141;p23"/>
+          <p:cNvPr id="151" name="Google Shape;151;p23"/>
           <p:cNvSpPr txBox="1"/>
           <p:nvPr>
             <p:ph idx="1" type="body"/>
@@ -7971,7 +8102,7 @@
       </p:sp>
       <p:sp>
         <p:nvSpPr>
-          <p:cNvPr id="142" name="Google Shape;142;p23"/>
+          <p:cNvPr id="152" name="Google Shape;152;p23"/>
           <p:cNvSpPr txBox="1"/>
           <p:nvPr>
             <p:ph idx="1" type="body"/>
@@ -8198,7 +8329,7 @@
   <p:cSld>
     <p:spTree>
       <p:nvGrpSpPr>
-        <p:cNvPr id="146" name="Shape 146"/>
+        <p:cNvPr id="156" name="Shape 156"/>
         <p:cNvGrpSpPr/>
         <p:nvPr/>
       </p:nvGrpSpPr>
@@ -8212,7 +8343,7 @@
       </p:grpSpPr>
       <p:sp>
         <p:nvSpPr>
-          <p:cNvPr id="147" name="Google Shape;147;p24"/>
+          <p:cNvPr id="157" name="Google Shape;157;p24"/>
           <p:cNvSpPr txBox="1"/>
           <p:nvPr>
             <p:ph type="ctrTitle"/>
@@ -8260,7 +8391,7 @@
       </p:sp>
       <p:sp>
         <p:nvSpPr>
-          <p:cNvPr id="148" name="Google Shape;148;p24"/>
+          <p:cNvPr id="158" name="Google Shape;158;p24"/>
           <p:cNvSpPr txBox="1"/>
           <p:nvPr>
             <p:ph idx="1" type="subTitle"/>
@@ -8319,7 +8450,7 @@
   <p:cSld>
     <p:spTree>
       <p:nvGrpSpPr>
-        <p:cNvPr id="64" name="Shape 64"/>
+        <p:cNvPr id="65" name="Shape 65"/>
         <p:cNvGrpSpPr/>
         <p:nvPr/>
       </p:nvGrpSpPr>
@@ -8333,7 +8464,7 @@
       </p:grpSpPr>
       <p:sp>
         <p:nvSpPr>
-          <p:cNvPr id="65" name="Google Shape;65;p14"/>
+          <p:cNvPr id="66" name="Google Shape;66;p14"/>
           <p:cNvSpPr txBox="1"/>
           <p:nvPr>
             <p:ph type="title"/>
@@ -8440,7 +8571,7 @@
       </p:sp>
       <p:sp>
         <p:nvSpPr>
-          <p:cNvPr id="66" name="Google Shape;66;p14"/>
+          <p:cNvPr id="67" name="Google Shape;67;p14"/>
           <p:cNvSpPr txBox="1"/>
           <p:nvPr>
             <p:ph idx="1" type="body"/>
@@ -8936,7 +9067,7 @@
       </p:sp>
       <p:pic>
         <p:nvPicPr>
-          <p:cNvPr id="67" name="Google Shape;67;p14"/>
+          <p:cNvPr id="68" name="Google Shape;68;p14"/>
           <p:cNvPicPr preferRelativeResize="0"/>
           <p:nvPr/>
         </p:nvPicPr>
@@ -8964,7 +9095,7 @@
       </p:pic>
       <p:sp>
         <p:nvSpPr>
-          <p:cNvPr id="68" name="Google Shape;68;p14"/>
+          <p:cNvPr id="69" name="Google Shape;69;p14"/>
           <p:cNvSpPr txBox="1"/>
           <p:nvPr/>
         </p:nvSpPr>
@@ -9178,6 +9309,64 @@
           </a:p>
         </p:txBody>
       </p:sp>
+      <p:sp>
+        <p:nvSpPr>
+          <p:cNvPr id="70" name="Google Shape;70;p14"/>
+          <p:cNvSpPr txBox="1"/>
+          <p:nvPr/>
+        </p:nvSpPr>
+        <p:spPr>
+          <a:xfrm>
+            <a:off x="8336550" y="173025"/>
+            <a:ext cx="807600" cy="306600"/>
+          </a:xfrm>
+          <a:prstGeom prst="rect">
+            <a:avLst/>
+          </a:prstGeom>
+          <a:noFill/>
+          <a:ln>
+            <a:noFill/>
+          </a:ln>
+        </p:spPr>
+        <p:txBody>
+          <a:bodyPr anchorCtr="0" anchor="t" bIns="91425" lIns="91425" spcFirstLastPara="1" rIns="91425" wrap="square" tIns="91425">
+            <a:noAutofit/>
+          </a:bodyPr>
+          <a:lstStyle/>
+          <a:p>
+            <a:pPr indent="0" lvl="0" marL="0" rtl="0" algn="l">
+              <a:spcBef>
+                <a:spcPts val="0"/>
+              </a:spcBef>
+              <a:spcAft>
+                <a:spcPts val="0"/>
+              </a:spcAft>
+              <a:buNone/>
+            </a:pPr>
+            <a:r>
+              <a:rPr lang="ru" sz="1800">
+                <a:solidFill>
+                  <a:schemeClr val="accent3"/>
+                </a:solidFill>
+                <a:latin typeface="Average"/>
+                <a:ea typeface="Average"/>
+                <a:cs typeface="Average"/>
+                <a:sym typeface="Average"/>
+              </a:rPr>
+              <a:t>A.</a:t>
+            </a:r>
+            <a:endParaRPr sz="1800">
+              <a:solidFill>
+                <a:schemeClr val="accent3"/>
+              </a:solidFill>
+              <a:latin typeface="Average"/>
+              <a:ea typeface="Average"/>
+              <a:cs typeface="Average"/>
+              <a:sym typeface="Average"/>
+            </a:endParaRPr>
+          </a:p>
+        </p:txBody>
+      </p:sp>
     </p:spTree>
   </p:cSld>
   <p:clrMapOvr>
@@ -9191,7 +9380,7 @@
   <p:cSld>
     <p:spTree>
       <p:nvGrpSpPr>
-        <p:cNvPr id="72" name="Shape 72"/>
+        <p:cNvPr id="74" name="Shape 74"/>
         <p:cNvGrpSpPr/>
         <p:nvPr/>
       </p:nvGrpSpPr>
@@ -9205,7 +9394,7 @@
       </p:grpSpPr>
       <p:sp>
         <p:nvSpPr>
-          <p:cNvPr id="73" name="Google Shape;73;p15"/>
+          <p:cNvPr id="75" name="Google Shape;75;p15"/>
           <p:cNvSpPr txBox="1"/>
           <p:nvPr>
             <p:ph type="title"/>
@@ -9279,7 +9468,7 @@
       </p:sp>
       <p:sp>
         <p:nvSpPr>
-          <p:cNvPr id="74" name="Google Shape;74;p15"/>
+          <p:cNvPr id="76" name="Google Shape;76;p15"/>
           <p:cNvSpPr txBox="1"/>
           <p:nvPr>
             <p:ph idx="1" type="body"/>
@@ -9699,7 +9888,7 @@
       </p:sp>
       <p:sp>
         <p:nvSpPr>
-          <p:cNvPr id="75" name="Google Shape;75;p15"/>
+          <p:cNvPr id="77" name="Google Shape;77;p15"/>
           <p:cNvSpPr txBox="1"/>
           <p:nvPr/>
         </p:nvSpPr>
@@ -9744,7 +9933,7 @@
                 <a:cs typeface="Courier New"/>
                 <a:sym typeface="Courier New"/>
               </a:rPr>
-              <a:t>AI core development and logic</a:t>
+              <a:t>AI core development and logic*</a:t>
             </a:r>
             <a:endParaRPr b="1" sz="1100">
               <a:solidFill>
@@ -9875,7 +10064,7 @@
       </p:sp>
       <p:sp>
         <p:nvSpPr>
-          <p:cNvPr id="76" name="Google Shape;76;p15"/>
+          <p:cNvPr id="78" name="Google Shape;78;p15"/>
           <p:cNvSpPr txBox="1"/>
           <p:nvPr/>
         </p:nvSpPr>
@@ -9943,6 +10132,64 @@
           </a:p>
         </p:txBody>
       </p:sp>
+      <p:sp>
+        <p:nvSpPr>
+          <p:cNvPr id="79" name="Google Shape;79;p15"/>
+          <p:cNvSpPr txBox="1"/>
+          <p:nvPr/>
+        </p:nvSpPr>
+        <p:spPr>
+          <a:xfrm>
+            <a:off x="8438800" y="133700"/>
+            <a:ext cx="865200" cy="369600"/>
+          </a:xfrm>
+          <a:prstGeom prst="rect">
+            <a:avLst/>
+          </a:prstGeom>
+          <a:noFill/>
+          <a:ln>
+            <a:noFill/>
+          </a:ln>
+        </p:spPr>
+        <p:txBody>
+          <a:bodyPr anchorCtr="0" anchor="t" bIns="91425" lIns="91425" spcFirstLastPara="1" rIns="91425" wrap="square" tIns="91425">
+            <a:noAutofit/>
+          </a:bodyPr>
+          <a:lstStyle/>
+          <a:p>
+            <a:pPr indent="0" lvl="0" marL="0" rtl="0" algn="l">
+              <a:spcBef>
+                <a:spcPts val="0"/>
+              </a:spcBef>
+              <a:spcAft>
+                <a:spcPts val="0"/>
+              </a:spcAft>
+              <a:buNone/>
+            </a:pPr>
+            <a:r>
+              <a:rPr lang="ru" sz="1800">
+                <a:solidFill>
+                  <a:schemeClr val="accent3"/>
+                </a:solidFill>
+                <a:latin typeface="Average"/>
+                <a:ea typeface="Average"/>
+                <a:cs typeface="Average"/>
+                <a:sym typeface="Average"/>
+              </a:rPr>
+              <a:t>A.</a:t>
+            </a:r>
+            <a:endParaRPr sz="1800">
+              <a:solidFill>
+                <a:schemeClr val="accent3"/>
+              </a:solidFill>
+              <a:latin typeface="Average"/>
+              <a:ea typeface="Average"/>
+              <a:cs typeface="Average"/>
+              <a:sym typeface="Average"/>
+            </a:endParaRPr>
+          </a:p>
+        </p:txBody>
+      </p:sp>
     </p:spTree>
   </p:cSld>
   <p:clrMapOvr>
@@ -9956,7 +10203,7 @@
   <p:cSld>
     <p:spTree>
       <p:nvGrpSpPr>
-        <p:cNvPr id="80" name="Shape 80"/>
+        <p:cNvPr id="83" name="Shape 83"/>
         <p:cNvGrpSpPr/>
         <p:nvPr/>
       </p:nvGrpSpPr>
@@ -9970,7 +10217,7 @@
       </p:grpSpPr>
       <p:sp>
         <p:nvSpPr>
-          <p:cNvPr id="81" name="Google Shape;81;p16"/>
+          <p:cNvPr id="84" name="Google Shape;84;p16"/>
           <p:cNvSpPr txBox="1"/>
           <p:nvPr>
             <p:ph type="title"/>
@@ -10018,7 +10265,7 @@
       </p:sp>
       <p:sp>
         <p:nvSpPr>
-          <p:cNvPr id="82" name="Google Shape;82;p16"/>
+          <p:cNvPr id="85" name="Google Shape;85;p16"/>
           <p:cNvSpPr txBox="1"/>
           <p:nvPr>
             <p:ph idx="1" type="body"/>
@@ -10049,32 +10296,44 @@
               <a:buNone/>
             </a:pPr>
             <a:r>
-              <a:rPr lang="ru">
+              <a:rPr lang="ru" sz="1200">
                 <a:solidFill>
                   <a:schemeClr val="accent5"/>
                 </a:solidFill>
+                <a:latin typeface="Courier New"/>
+                <a:ea typeface="Courier New"/>
+                <a:cs typeface="Courier New"/>
+                <a:sym typeface="Courier New"/>
               </a:rPr>
               <a:t>Initial</a:t>
             </a:r>
             <a:r>
-              <a:rPr lang="ru">
+              <a:rPr lang="ru" sz="1200">
                 <a:solidFill>
                   <a:schemeClr val="accent5"/>
                 </a:solidFill>
+                <a:latin typeface="Courier New"/>
+                <a:ea typeface="Courier New"/>
+                <a:cs typeface="Courier New"/>
+                <a:sym typeface="Courier New"/>
               </a:rPr>
               <a:t> sketch:</a:t>
             </a:r>
-            <a:endParaRPr>
+            <a:endParaRPr sz="1200">
               <a:solidFill>
                 <a:schemeClr val="accent5"/>
               </a:solidFill>
+              <a:latin typeface="Courier New"/>
+              <a:ea typeface="Courier New"/>
+              <a:cs typeface="Courier New"/>
+              <a:sym typeface="Courier New"/>
             </a:endParaRPr>
           </a:p>
         </p:txBody>
       </p:sp>
       <p:pic>
         <p:nvPicPr>
-          <p:cNvPr id="83" name="Google Shape;83;p16"/>
+          <p:cNvPr id="86" name="Google Shape;86;p16"/>
           <p:cNvPicPr preferRelativeResize="0"/>
           <p:nvPr/>
         </p:nvPicPr>
@@ -10102,7 +10361,7 @@
       </p:pic>
       <p:pic>
         <p:nvPicPr>
-          <p:cNvPr id="84" name="Google Shape;84;p16"/>
+          <p:cNvPr id="87" name="Google Shape;87;p16"/>
           <p:cNvPicPr preferRelativeResize="0"/>
           <p:nvPr/>
         </p:nvPicPr>
@@ -10130,7 +10389,7 @@
       </p:pic>
       <p:sp>
         <p:nvSpPr>
-          <p:cNvPr id="85" name="Google Shape;85;p16"/>
+          <p:cNvPr id="88" name="Google Shape;88;p16"/>
           <p:cNvSpPr txBox="1"/>
           <p:nvPr/>
         </p:nvSpPr>
@@ -10163,6 +10422,108 @@
               <a:buNone/>
             </a:pPr>
             <a:r>
+              <a:rPr lang="ru" sz="1200">
+                <a:solidFill>
+                  <a:schemeClr val="accent3"/>
+                </a:solidFill>
+                <a:latin typeface="Courier New"/>
+                <a:ea typeface="Courier New"/>
+                <a:cs typeface="Courier New"/>
+                <a:sym typeface="Courier New"/>
+              </a:rPr>
+              <a:t> </a:t>
+            </a:r>
+            <a:r>
+              <a:rPr lang="ru" sz="1200">
+                <a:solidFill>
+                  <a:schemeClr val="accent5"/>
+                </a:solidFill>
+                <a:latin typeface="Courier New"/>
+                <a:ea typeface="Courier New"/>
+                <a:cs typeface="Courier New"/>
+                <a:sym typeface="Courier New"/>
+              </a:rPr>
+              <a:t>← AI’s response </a:t>
+            </a:r>
+            <a:endParaRPr sz="1200">
+              <a:solidFill>
+                <a:schemeClr val="accent5"/>
+              </a:solidFill>
+              <a:latin typeface="Courier New"/>
+              <a:ea typeface="Courier New"/>
+              <a:cs typeface="Courier New"/>
+              <a:sym typeface="Courier New"/>
+            </a:endParaRPr>
+          </a:p>
+          <a:p>
+            <a:pPr indent="0" lvl="0" marL="0" rtl="0" algn="l">
+              <a:spcBef>
+                <a:spcPts val="0"/>
+              </a:spcBef>
+              <a:spcAft>
+                <a:spcPts val="0"/>
+              </a:spcAft>
+              <a:buNone/>
+            </a:pPr>
+            <a:r>
+              <a:rPr lang="ru" sz="1200">
+                <a:solidFill>
+                  <a:schemeClr val="accent5"/>
+                </a:solidFill>
+                <a:latin typeface="Courier New"/>
+                <a:ea typeface="Courier New"/>
+                <a:cs typeface="Courier New"/>
+                <a:sym typeface="Courier New"/>
+              </a:rPr>
+              <a:t>   to the sketch</a:t>
+            </a:r>
+            <a:endParaRPr sz="1200">
+              <a:solidFill>
+                <a:schemeClr val="accent5"/>
+              </a:solidFill>
+              <a:latin typeface="Courier New"/>
+              <a:ea typeface="Courier New"/>
+              <a:cs typeface="Courier New"/>
+              <a:sym typeface="Courier New"/>
+            </a:endParaRPr>
+          </a:p>
+        </p:txBody>
+      </p:sp>
+      <p:sp>
+        <p:nvSpPr>
+          <p:cNvPr id="89" name="Google Shape;89;p16"/>
+          <p:cNvSpPr txBox="1"/>
+          <p:nvPr/>
+        </p:nvSpPr>
+        <p:spPr>
+          <a:xfrm>
+            <a:off x="8438800" y="133700"/>
+            <a:ext cx="865200" cy="369600"/>
+          </a:xfrm>
+          <a:prstGeom prst="rect">
+            <a:avLst/>
+          </a:prstGeom>
+          <a:noFill/>
+          <a:ln>
+            <a:noFill/>
+          </a:ln>
+        </p:spPr>
+        <p:txBody>
+          <a:bodyPr anchorCtr="0" anchor="t" bIns="91425" lIns="91425" spcFirstLastPara="1" rIns="91425" wrap="square" tIns="91425">
+            <a:noAutofit/>
+          </a:bodyPr>
+          <a:lstStyle/>
+          <a:p>
+            <a:pPr indent="0" lvl="0" marL="0" rtl="0" algn="l">
+              <a:spcBef>
+                <a:spcPts val="0"/>
+              </a:spcBef>
+              <a:spcAft>
+                <a:spcPts val="0"/>
+              </a:spcAft>
+              <a:buNone/>
+            </a:pPr>
+            <a:r>
               <a:rPr lang="ru" sz="1800">
                 <a:solidFill>
                   <a:schemeClr val="accent3"/>
@@ -10172,55 +10533,23 @@
                 <a:cs typeface="Average"/>
                 <a:sym typeface="Average"/>
               </a:rPr>
-              <a:t> </a:t>
+              <a:t>S</a:t>
             </a:r>
             <a:r>
               <a:rPr lang="ru" sz="1800">
                 <a:solidFill>
-                  <a:schemeClr val="accent5"/>
+                  <a:schemeClr val="accent3"/>
                 </a:solidFill>
                 <a:latin typeface="Average"/>
                 <a:ea typeface="Average"/>
                 <a:cs typeface="Average"/>
                 <a:sym typeface="Average"/>
               </a:rPr>
-              <a:t>← AI’s response </a:t>
+              <a:t>.</a:t>
             </a:r>
             <a:endParaRPr sz="1800">
               <a:solidFill>
-                <a:schemeClr val="accent5"/>
-              </a:solidFill>
-              <a:latin typeface="Average"/>
-              <a:ea typeface="Average"/>
-              <a:cs typeface="Average"/>
-              <a:sym typeface="Average"/>
-            </a:endParaRPr>
-          </a:p>
-          <a:p>
-            <a:pPr indent="0" lvl="0" marL="0" rtl="0" algn="l">
-              <a:spcBef>
-                <a:spcPts val="0"/>
-              </a:spcBef>
-              <a:spcAft>
-                <a:spcPts val="0"/>
-              </a:spcAft>
-              <a:buNone/>
-            </a:pPr>
-            <a:r>
-              <a:rPr lang="ru" sz="1800">
-                <a:solidFill>
-                  <a:schemeClr val="accent5"/>
-                </a:solidFill>
-                <a:latin typeface="Average"/>
-                <a:ea typeface="Average"/>
-                <a:cs typeface="Average"/>
-                <a:sym typeface="Average"/>
-              </a:rPr>
-              <a:t>       to the sketch</a:t>
-            </a:r>
-            <a:endParaRPr sz="1800">
-              <a:solidFill>
-                <a:schemeClr val="accent5"/>
+                <a:schemeClr val="accent3"/>
               </a:solidFill>
               <a:latin typeface="Average"/>
               <a:ea typeface="Average"/>
@@ -10243,7 +10572,7 @@
   <p:cSld>
     <p:spTree>
       <p:nvGrpSpPr>
-        <p:cNvPr id="89" name="Shape 89"/>
+        <p:cNvPr id="93" name="Shape 93"/>
         <p:cNvGrpSpPr/>
         <p:nvPr/>
       </p:nvGrpSpPr>
@@ -10257,7 +10586,7 @@
       </p:grpSpPr>
       <p:sp>
         <p:nvSpPr>
-          <p:cNvPr id="90" name="Google Shape;90;p17"/>
+          <p:cNvPr id="94" name="Google Shape;94;p17"/>
           <p:cNvSpPr txBox="1"/>
           <p:nvPr>
             <p:ph type="title"/>
@@ -10309,7 +10638,7 @@
       </p:sp>
       <p:sp>
         <p:nvSpPr>
-          <p:cNvPr id="91" name="Google Shape;91;p17"/>
+          <p:cNvPr id="95" name="Google Shape;95;p17"/>
           <p:cNvSpPr txBox="1"/>
           <p:nvPr>
             <p:ph idx="1" type="body"/>
@@ -10492,7 +10821,7 @@
       </p:sp>
       <p:pic>
         <p:nvPicPr>
-          <p:cNvPr id="92" name="Google Shape;92;p17"/>
+          <p:cNvPr id="96" name="Google Shape;96;p17"/>
           <p:cNvPicPr preferRelativeResize="0"/>
           <p:nvPr/>
         </p:nvPicPr>
@@ -10520,7 +10849,7 @@
       </p:pic>
       <p:pic>
         <p:nvPicPr>
-          <p:cNvPr id="93" name="Google Shape;93;p17"/>
+          <p:cNvPr id="97" name="Google Shape;97;p17"/>
           <p:cNvPicPr preferRelativeResize="0"/>
           <p:nvPr/>
         </p:nvPicPr>
@@ -10548,7 +10877,7 @@
       </p:pic>
       <p:pic>
         <p:nvPicPr>
-          <p:cNvPr id="94" name="Google Shape;94;p17"/>
+          <p:cNvPr id="98" name="Google Shape;98;p17"/>
           <p:cNvPicPr preferRelativeResize="0"/>
           <p:nvPr/>
         </p:nvPicPr>
@@ -10576,7 +10905,7 @@
       </p:pic>
       <p:pic>
         <p:nvPicPr>
-          <p:cNvPr id="95" name="Google Shape;95;p17"/>
+          <p:cNvPr id="99" name="Google Shape;99;p17"/>
           <p:cNvPicPr preferRelativeResize="0"/>
           <p:nvPr/>
         </p:nvPicPr>
@@ -10604,7 +10933,7 @@
       </p:pic>
       <p:sp>
         <p:nvSpPr>
-          <p:cNvPr id="96" name="Google Shape;96;p17"/>
+          <p:cNvPr id="100" name="Google Shape;100;p17"/>
           <p:cNvSpPr txBox="1"/>
           <p:nvPr/>
         </p:nvSpPr>
@@ -10662,7 +10991,7 @@
       </p:sp>
       <p:sp>
         <p:nvSpPr>
-          <p:cNvPr id="97" name="Google Shape;97;p17"/>
+          <p:cNvPr id="101" name="Google Shape;101;p17"/>
           <p:cNvSpPr txBox="1"/>
           <p:nvPr/>
         </p:nvSpPr>
@@ -10730,6 +11059,76 @@
           </a:p>
         </p:txBody>
       </p:sp>
+      <p:sp>
+        <p:nvSpPr>
+          <p:cNvPr id="102" name="Google Shape;102;p17"/>
+          <p:cNvSpPr txBox="1"/>
+          <p:nvPr/>
+        </p:nvSpPr>
+        <p:spPr>
+          <a:xfrm>
+            <a:off x="8438800" y="133700"/>
+            <a:ext cx="865200" cy="369600"/>
+          </a:xfrm>
+          <a:prstGeom prst="rect">
+            <a:avLst/>
+          </a:prstGeom>
+          <a:noFill/>
+          <a:ln>
+            <a:noFill/>
+          </a:ln>
+        </p:spPr>
+        <p:txBody>
+          <a:bodyPr anchorCtr="0" anchor="t" bIns="91425" lIns="91425" spcFirstLastPara="1" rIns="91425" wrap="square" tIns="91425">
+            <a:noAutofit/>
+          </a:bodyPr>
+          <a:lstStyle/>
+          <a:p>
+            <a:pPr indent="0" lvl="0" marL="0" rtl="0" algn="l">
+              <a:spcBef>
+                <a:spcPts val="0"/>
+              </a:spcBef>
+              <a:spcAft>
+                <a:spcPts val="0"/>
+              </a:spcAft>
+              <a:buNone/>
+            </a:pPr>
+            <a:r>
+              <a:rPr lang="ru" sz="1800">
+                <a:solidFill>
+                  <a:schemeClr val="accent3"/>
+                </a:solidFill>
+                <a:latin typeface="Average"/>
+                <a:ea typeface="Average"/>
+                <a:cs typeface="Average"/>
+                <a:sym typeface="Average"/>
+              </a:rPr>
+              <a:t>S</a:t>
+            </a:r>
+            <a:r>
+              <a:rPr lang="ru" sz="1800">
+                <a:solidFill>
+                  <a:schemeClr val="accent3"/>
+                </a:solidFill>
+                <a:latin typeface="Average"/>
+                <a:ea typeface="Average"/>
+                <a:cs typeface="Average"/>
+                <a:sym typeface="Average"/>
+              </a:rPr>
+              <a:t>.</a:t>
+            </a:r>
+            <a:endParaRPr sz="1800">
+              <a:solidFill>
+                <a:schemeClr val="accent3"/>
+              </a:solidFill>
+              <a:latin typeface="Average"/>
+              <a:ea typeface="Average"/>
+              <a:cs typeface="Average"/>
+              <a:sym typeface="Average"/>
+            </a:endParaRPr>
+          </a:p>
+        </p:txBody>
+      </p:sp>
     </p:spTree>
   </p:cSld>
   <p:clrMapOvr>
@@ -10743,7 +11142,7 @@
   <p:cSld>
     <p:spTree>
       <p:nvGrpSpPr>
-        <p:cNvPr id="101" name="Shape 101"/>
+        <p:cNvPr id="106" name="Shape 106"/>
         <p:cNvGrpSpPr/>
         <p:nvPr/>
       </p:nvGrpSpPr>
@@ -10757,7 +11156,7 @@
       </p:grpSpPr>
       <p:sp>
         <p:nvSpPr>
-          <p:cNvPr id="102" name="Google Shape;102;p18"/>
+          <p:cNvPr id="107" name="Google Shape;107;p18"/>
           <p:cNvSpPr txBox="1"/>
           <p:nvPr>
             <p:ph type="title"/>
@@ -10801,7 +11200,7 @@
       </p:sp>
       <p:sp>
         <p:nvSpPr>
-          <p:cNvPr id="103" name="Google Shape;103;p18"/>
+          <p:cNvPr id="108" name="Google Shape;108;p18"/>
           <p:cNvSpPr txBox="1"/>
           <p:nvPr>
             <p:ph idx="1" type="body"/>
@@ -10973,7 +11372,7 @@
       </p:sp>
       <p:pic>
         <p:nvPicPr>
-          <p:cNvPr id="104" name="Google Shape;104;p18"/>
+          <p:cNvPr id="109" name="Google Shape;109;p18"/>
           <p:cNvPicPr preferRelativeResize="0"/>
           <p:nvPr/>
         </p:nvPicPr>
@@ -11001,7 +11400,7 @@
       </p:pic>
       <p:sp>
         <p:nvSpPr>
-          <p:cNvPr id="105" name="Google Shape;105;p18"/>
+          <p:cNvPr id="110" name="Google Shape;110;p18"/>
           <p:cNvSpPr txBox="1"/>
           <p:nvPr/>
         </p:nvSpPr>
@@ -11042,7 +11441,7 @@
       </p:sp>
       <p:pic>
         <p:nvPicPr>
-          <p:cNvPr id="106" name="Google Shape;106;p18"/>
+          <p:cNvPr id="111" name="Google Shape;111;p18"/>
           <p:cNvPicPr preferRelativeResize="0"/>
           <p:nvPr/>
         </p:nvPicPr>
@@ -11068,6 +11467,76 @@
           </a:ln>
         </p:spPr>
       </p:pic>
+      <p:sp>
+        <p:nvSpPr>
+          <p:cNvPr id="112" name="Google Shape;112;p18"/>
+          <p:cNvSpPr txBox="1"/>
+          <p:nvPr/>
+        </p:nvSpPr>
+        <p:spPr>
+          <a:xfrm>
+            <a:off x="8438800" y="133700"/>
+            <a:ext cx="865200" cy="369600"/>
+          </a:xfrm>
+          <a:prstGeom prst="rect">
+            <a:avLst/>
+          </a:prstGeom>
+          <a:noFill/>
+          <a:ln>
+            <a:noFill/>
+          </a:ln>
+        </p:spPr>
+        <p:txBody>
+          <a:bodyPr anchorCtr="0" anchor="t" bIns="91425" lIns="91425" spcFirstLastPara="1" rIns="91425" wrap="square" tIns="91425">
+            <a:noAutofit/>
+          </a:bodyPr>
+          <a:lstStyle/>
+          <a:p>
+            <a:pPr indent="0" lvl="0" marL="0" rtl="0" algn="l">
+              <a:spcBef>
+                <a:spcPts val="0"/>
+              </a:spcBef>
+              <a:spcAft>
+                <a:spcPts val="0"/>
+              </a:spcAft>
+              <a:buNone/>
+            </a:pPr>
+            <a:r>
+              <a:rPr lang="ru" sz="1800">
+                <a:solidFill>
+                  <a:schemeClr val="accent3"/>
+                </a:solidFill>
+                <a:latin typeface="Average"/>
+                <a:ea typeface="Average"/>
+                <a:cs typeface="Average"/>
+                <a:sym typeface="Average"/>
+              </a:rPr>
+              <a:t>S</a:t>
+            </a:r>
+            <a:r>
+              <a:rPr lang="ru" sz="1800">
+                <a:solidFill>
+                  <a:schemeClr val="accent3"/>
+                </a:solidFill>
+                <a:latin typeface="Average"/>
+                <a:ea typeface="Average"/>
+                <a:cs typeface="Average"/>
+                <a:sym typeface="Average"/>
+              </a:rPr>
+              <a:t>.</a:t>
+            </a:r>
+            <a:endParaRPr sz="1800">
+              <a:solidFill>
+                <a:schemeClr val="accent3"/>
+              </a:solidFill>
+              <a:latin typeface="Average"/>
+              <a:ea typeface="Average"/>
+              <a:cs typeface="Average"/>
+              <a:sym typeface="Average"/>
+            </a:endParaRPr>
+          </a:p>
+        </p:txBody>
+      </p:sp>
     </p:spTree>
   </p:cSld>
   <p:clrMapOvr>
@@ -11081,7 +11550,7 @@
   <p:cSld>
     <p:spTree>
       <p:nvGrpSpPr>
-        <p:cNvPr id="110" name="Shape 110"/>
+        <p:cNvPr id="116" name="Shape 116"/>
         <p:cNvGrpSpPr/>
         <p:nvPr/>
       </p:nvGrpSpPr>
@@ -11095,7 +11564,7 @@
       </p:grpSpPr>
       <p:sp>
         <p:nvSpPr>
-          <p:cNvPr id="111" name="Google Shape;111;p19"/>
+          <p:cNvPr id="117" name="Google Shape;117;p19"/>
           <p:cNvSpPr txBox="1"/>
           <p:nvPr>
             <p:ph type="title"/>
@@ -11143,7 +11612,7 @@
       </p:sp>
       <p:sp>
         <p:nvSpPr>
-          <p:cNvPr id="112" name="Google Shape;112;p19"/>
+          <p:cNvPr id="118" name="Google Shape;118;p19"/>
           <p:cNvSpPr txBox="1"/>
           <p:nvPr>
             <p:ph idx="1" type="body"/>
@@ -11449,7 +11918,7 @@
       </p:sp>
       <p:pic>
         <p:nvPicPr>
-          <p:cNvPr id="113" name="Google Shape;113;p19"/>
+          <p:cNvPr id="119" name="Google Shape;119;p19"/>
           <p:cNvPicPr preferRelativeResize="0"/>
           <p:nvPr/>
         </p:nvPicPr>
@@ -11463,8 +11932,8 @@
         </p:blipFill>
         <p:spPr>
           <a:xfrm>
-            <a:off x="6767200" y="203238"/>
-            <a:ext cx="2142450" cy="4737023"/>
+            <a:off x="6767200" y="894200"/>
+            <a:ext cx="1829949" cy="4046050"/>
           </a:xfrm>
           <a:prstGeom prst="rect">
             <a:avLst/>
@@ -11475,6 +11944,76 @@
           </a:ln>
         </p:spPr>
       </p:pic>
+      <p:sp>
+        <p:nvSpPr>
+          <p:cNvPr id="120" name="Google Shape;120;p19"/>
+          <p:cNvSpPr txBox="1"/>
+          <p:nvPr/>
+        </p:nvSpPr>
+        <p:spPr>
+          <a:xfrm>
+            <a:off x="8438800" y="133700"/>
+            <a:ext cx="865200" cy="369600"/>
+          </a:xfrm>
+          <a:prstGeom prst="rect">
+            <a:avLst/>
+          </a:prstGeom>
+          <a:noFill/>
+          <a:ln>
+            <a:noFill/>
+          </a:ln>
+        </p:spPr>
+        <p:txBody>
+          <a:bodyPr anchorCtr="0" anchor="t" bIns="91425" lIns="91425" spcFirstLastPara="1" rIns="91425" wrap="square" tIns="91425">
+            <a:noAutofit/>
+          </a:bodyPr>
+          <a:lstStyle/>
+          <a:p>
+            <a:pPr indent="0" lvl="0" marL="0" rtl="0" algn="l">
+              <a:spcBef>
+                <a:spcPts val="0"/>
+              </a:spcBef>
+              <a:spcAft>
+                <a:spcPts val="0"/>
+              </a:spcAft>
+              <a:buNone/>
+            </a:pPr>
+            <a:r>
+              <a:rPr lang="ru" sz="1800">
+                <a:solidFill>
+                  <a:schemeClr val="accent3"/>
+                </a:solidFill>
+                <a:latin typeface="Average"/>
+                <a:ea typeface="Average"/>
+                <a:cs typeface="Average"/>
+                <a:sym typeface="Average"/>
+              </a:rPr>
+              <a:t>T</a:t>
+            </a:r>
+            <a:r>
+              <a:rPr lang="ru" sz="1800">
+                <a:solidFill>
+                  <a:schemeClr val="accent3"/>
+                </a:solidFill>
+                <a:latin typeface="Average"/>
+                <a:ea typeface="Average"/>
+                <a:cs typeface="Average"/>
+                <a:sym typeface="Average"/>
+              </a:rPr>
+              <a:t>.</a:t>
+            </a:r>
+            <a:endParaRPr sz="1800">
+              <a:solidFill>
+                <a:schemeClr val="accent3"/>
+              </a:solidFill>
+              <a:latin typeface="Average"/>
+              <a:ea typeface="Average"/>
+              <a:cs typeface="Average"/>
+              <a:sym typeface="Average"/>
+            </a:endParaRPr>
+          </a:p>
+        </p:txBody>
+      </p:sp>
     </p:spTree>
   </p:cSld>
   <p:clrMapOvr>
@@ -11488,7 +12027,7 @@
   <p:cSld>
     <p:spTree>
       <p:nvGrpSpPr>
-        <p:cNvPr id="117" name="Shape 117"/>
+        <p:cNvPr id="124" name="Shape 124"/>
         <p:cNvGrpSpPr/>
         <p:nvPr/>
       </p:nvGrpSpPr>
@@ -11502,7 +12041,7 @@
       </p:grpSpPr>
       <p:sp>
         <p:nvSpPr>
-          <p:cNvPr id="118" name="Google Shape;118;p20"/>
+          <p:cNvPr id="125" name="Google Shape;125;p20"/>
           <p:cNvSpPr txBox="1"/>
           <p:nvPr>
             <p:ph idx="1" type="body"/>
@@ -11576,7 +12115,7 @@
       </p:sp>
       <p:sp>
         <p:nvSpPr>
-          <p:cNvPr id="119" name="Google Shape;119;p20"/>
+          <p:cNvPr id="126" name="Google Shape;126;p20"/>
           <p:cNvSpPr txBox="1"/>
           <p:nvPr>
             <p:ph type="title"/>
@@ -11624,7 +12163,7 @@
       </p:sp>
       <p:pic>
         <p:nvPicPr>
-          <p:cNvPr id="120" name="Google Shape;120;p20"/>
+          <p:cNvPr id="127" name="Google Shape;127;p20"/>
           <p:cNvPicPr preferRelativeResize="0"/>
           <p:nvPr/>
         </p:nvPicPr>
@@ -11650,6 +12189,76 @@
           </a:ln>
         </p:spPr>
       </p:pic>
+      <p:sp>
+        <p:nvSpPr>
+          <p:cNvPr id="128" name="Google Shape;128;p20"/>
+          <p:cNvSpPr txBox="1"/>
+          <p:nvPr/>
+        </p:nvSpPr>
+        <p:spPr>
+          <a:xfrm>
+            <a:off x="8438800" y="133700"/>
+            <a:ext cx="865200" cy="369600"/>
+          </a:xfrm>
+          <a:prstGeom prst="rect">
+            <a:avLst/>
+          </a:prstGeom>
+          <a:noFill/>
+          <a:ln>
+            <a:noFill/>
+          </a:ln>
+        </p:spPr>
+        <p:txBody>
+          <a:bodyPr anchorCtr="0" anchor="t" bIns="91425" lIns="91425" spcFirstLastPara="1" rIns="91425" wrap="square" tIns="91425">
+            <a:noAutofit/>
+          </a:bodyPr>
+          <a:lstStyle/>
+          <a:p>
+            <a:pPr indent="0" lvl="0" marL="0" rtl="0" algn="l">
+              <a:spcBef>
+                <a:spcPts val="0"/>
+              </a:spcBef>
+              <a:spcAft>
+                <a:spcPts val="0"/>
+              </a:spcAft>
+              <a:buNone/>
+            </a:pPr>
+            <a:r>
+              <a:rPr lang="ru" sz="1800">
+                <a:solidFill>
+                  <a:schemeClr val="accent3"/>
+                </a:solidFill>
+                <a:latin typeface="Average"/>
+                <a:ea typeface="Average"/>
+                <a:cs typeface="Average"/>
+                <a:sym typeface="Average"/>
+              </a:rPr>
+              <a:t>T</a:t>
+            </a:r>
+            <a:r>
+              <a:rPr lang="ru" sz="1800">
+                <a:solidFill>
+                  <a:schemeClr val="accent3"/>
+                </a:solidFill>
+                <a:latin typeface="Average"/>
+                <a:ea typeface="Average"/>
+                <a:cs typeface="Average"/>
+                <a:sym typeface="Average"/>
+              </a:rPr>
+              <a:t>.</a:t>
+            </a:r>
+            <a:endParaRPr sz="1800">
+              <a:solidFill>
+                <a:schemeClr val="accent3"/>
+              </a:solidFill>
+              <a:latin typeface="Average"/>
+              <a:ea typeface="Average"/>
+              <a:cs typeface="Average"/>
+              <a:sym typeface="Average"/>
+            </a:endParaRPr>
+          </a:p>
+        </p:txBody>
+      </p:sp>
     </p:spTree>
   </p:cSld>
   <p:clrMapOvr>
@@ -11663,7 +12272,7 @@
   <p:cSld>
     <p:spTree>
       <p:nvGrpSpPr>
-        <p:cNvPr id="124" name="Shape 124"/>
+        <p:cNvPr id="132" name="Shape 132"/>
         <p:cNvGrpSpPr/>
         <p:nvPr/>
       </p:nvGrpSpPr>
@@ -11677,7 +12286,7 @@
       </p:grpSpPr>
       <p:sp>
         <p:nvSpPr>
-          <p:cNvPr id="125" name="Google Shape;125;p21"/>
+          <p:cNvPr id="133" name="Google Shape;133;p21"/>
           <p:cNvSpPr txBox="1"/>
           <p:nvPr>
             <p:ph type="title"/>
@@ -11744,7 +12353,7 @@
       </p:sp>
       <p:sp>
         <p:nvSpPr>
-          <p:cNvPr id="126" name="Google Shape;126;p21"/>
+          <p:cNvPr id="134" name="Google Shape;134;p21"/>
           <p:cNvSpPr txBox="1"/>
           <p:nvPr>
             <p:ph idx="1" type="body"/>
@@ -11867,7 +12476,7 @@
       </p:sp>
       <p:pic>
         <p:nvPicPr>
-          <p:cNvPr id="127" name="Google Shape;127;p21"/>
+          <p:cNvPr id="135" name="Google Shape;135;p21"/>
           <p:cNvPicPr preferRelativeResize="0"/>
           <p:nvPr/>
         </p:nvPicPr>
@@ -11881,8 +12490,8 @@
         </p:blipFill>
         <p:spPr>
           <a:xfrm>
-            <a:off x="6884775" y="438750"/>
-            <a:ext cx="1859124" cy="4265998"/>
+            <a:off x="6798875" y="892021"/>
+            <a:ext cx="1773450" cy="4069403"/>
           </a:xfrm>
           <a:prstGeom prst="rect">
             <a:avLst/>
@@ -11893,6 +12502,76 @@
           </a:ln>
         </p:spPr>
       </p:pic>
+      <p:sp>
+        <p:nvSpPr>
+          <p:cNvPr id="136" name="Google Shape;136;p21"/>
+          <p:cNvSpPr txBox="1"/>
+          <p:nvPr/>
+        </p:nvSpPr>
+        <p:spPr>
+          <a:xfrm>
+            <a:off x="8438800" y="133700"/>
+            <a:ext cx="865200" cy="369600"/>
+          </a:xfrm>
+          <a:prstGeom prst="rect">
+            <a:avLst/>
+          </a:prstGeom>
+          <a:noFill/>
+          <a:ln>
+            <a:noFill/>
+          </a:ln>
+        </p:spPr>
+        <p:txBody>
+          <a:bodyPr anchorCtr="0" anchor="t" bIns="91425" lIns="91425" spcFirstLastPara="1" rIns="91425" wrap="square" tIns="91425">
+            <a:noAutofit/>
+          </a:bodyPr>
+          <a:lstStyle/>
+          <a:p>
+            <a:pPr indent="0" lvl="0" marL="0" rtl="0" algn="l">
+              <a:spcBef>
+                <a:spcPts val="0"/>
+              </a:spcBef>
+              <a:spcAft>
+                <a:spcPts val="0"/>
+              </a:spcAft>
+              <a:buNone/>
+            </a:pPr>
+            <a:r>
+              <a:rPr lang="ru" sz="1800">
+                <a:solidFill>
+                  <a:schemeClr val="accent3"/>
+                </a:solidFill>
+                <a:latin typeface="Average"/>
+                <a:ea typeface="Average"/>
+                <a:cs typeface="Average"/>
+                <a:sym typeface="Average"/>
+              </a:rPr>
+              <a:t>T</a:t>
+            </a:r>
+            <a:r>
+              <a:rPr lang="ru" sz="1800">
+                <a:solidFill>
+                  <a:schemeClr val="accent3"/>
+                </a:solidFill>
+                <a:latin typeface="Average"/>
+                <a:ea typeface="Average"/>
+                <a:cs typeface="Average"/>
+                <a:sym typeface="Average"/>
+              </a:rPr>
+              <a:t>.</a:t>
+            </a:r>
+            <a:endParaRPr sz="1800">
+              <a:solidFill>
+                <a:schemeClr val="accent3"/>
+              </a:solidFill>
+              <a:latin typeface="Average"/>
+              <a:ea typeface="Average"/>
+              <a:cs typeface="Average"/>
+              <a:sym typeface="Average"/>
+            </a:endParaRPr>
+          </a:p>
+        </p:txBody>
+      </p:sp>
     </p:spTree>
   </p:cSld>
   <p:clrMapOvr>

</xml_diff>